<commit_message>
infra: recover EKS networking without consuming existing Elastic IP quota
</commit_message>
<xml_diff>
--- a/demo/presentation.pptx
+++ b/demo/presentation.pptx
@@ -6244,7 +6244,7 @@
               </a:defRPr>
             </a:pPr>
             <a:r>
-              <a:t>EKS worker nodes use private subnets; a NAT gateway provides outbound access.</a:t>
+              <a:t>Temporary workers use public subnets with automatic public IPs. Security groups allow no public inbound traffic.</a:t>
             </a:r>
           </a:p>
         </p:txBody>
@@ -6316,7 +6316,7 @@
               </a:defRPr>
             </a:pPr>
             <a:r>
-              <a:t>The Kubernetes API public endpoint is restricted to explicit operator CIDRs.</a:t>
+              <a:t>The account had no Elastic IP quota available, so the demo uses no NAT gateway.</a:t>
             </a:r>
           </a:p>
         </p:txBody>
@@ -6388,7 +6388,7 @@
               </a:defRPr>
             </a:pPr>
             <a:r>
-              <a:t>EBS CSI receives a dedicated IAM role for persistent volumes.</a:t>
+              <a:t>The Kubernetes API is restricted to the operator IP. EBS CSI uses a dedicated IAM role.</a:t>
             </a:r>
           </a:p>
         </p:txBody>
@@ -6460,7 +6460,7 @@
               </a:defRPr>
             </a:pPr>
             <a:r>
-              <a:t>Capture plan/apply and AWS proof, then destroy temporary billable resources.</a:t>
+              <a:t>Capture successful plan, apply and console proof, then destroy temporary resources.</a:t>
             </a:r>
           </a:p>
         </p:txBody>

</xml_diff>

<commit_message>
Prepare final presentation PDF and exact ResolveDesk presenter guide
</commit_message>
<xml_diff>
--- a/demo/presentation.pptx
+++ b/demo/presentation.pptx
@@ -3136,7 +3136,7 @@
               </a:defRPr>
             </a:pPr>
             <a:r>
-              <a:t>A HELPDESK APPLICATION WITH A REPRODUCIBLE DEVSECOPS DELIVERY PATH</a:t>
+              <a:t>RESOLVEDESK | DIBYO10 | HELPDESK TRIAGE AND VERIFIED DELIVERY</a:t>
             </a:r>
           </a:p>
         </p:txBody>
@@ -3388,7 +3388,7 @@
               </a:defRPr>
             </a:pPr>
             <a:r>
-              <a:t>Built for the DevSecOps assignment. Temporary AWS resources are removed after evidence capture.</a:t>
+              <a:t>Verified locally and on shared AWS EKS. Temporary cloud resources were removed after recording.</a:t>
             </a:r>
           </a:p>
         </p:txBody>
@@ -3522,7 +3522,7 @@
               </a:defRPr>
             </a:pPr>
             <a:r>
-              <a:t>WHAT IS VERIFIED, AND WHAT STILL NEEDS PROOF</a:t>
+              <a:t>VERIFIED RESULTS AND HONEST LIMITS</a:t>
             </a:r>
           </a:p>
         </p:txBody>
@@ -3630,7 +3630,7 @@
               </a:defRPr>
             </a:pPr>
             <a:r>
-              <a:t>Verified: 26 isolated backend tests, including validation, CRUD, readiness and migration waiting.</a:t>
+              <a:t>26 backend tests and four frontend tests passed; CI built, scanned, smoke-tested and published both images.</a:t>
             </a:r>
           </a:p>
         </p:txBody>
@@ -3702,7 +3702,7 @@
               </a:defRPr>
             </a:pPr>
             <a:r>
-              <a:t>Verified: Alembic migration round-trip and real HTTP CRUD against the local PostgreSQL deployment.</a:t>
+              <a:t>Recorded EKS deployment: working ingress, ArgoCD Synced/Healthy, two backend monitoring targets UP and populated Grafana panels.</a:t>
             </a:r>
           </a:p>
         </p:txBody>
@@ -3774,7 +3774,7 @@
               </a:defRPr>
             </a:pPr>
             <a:r>
-              <a:t>Runtime evidence: see demo/evidence and the final walkthrough for the recorded deployment state.</a:t>
+              <a:t>Terraform destroy removed 59 resources; all 11 cleanup checks passed. KMS deletion is scheduled for November 15, 2026.</a:t>
             </a:r>
           </a:p>
         </p:txBody>
@@ -3846,7 +3846,7 @@
               </a:defRPr>
             </a:pPr>
             <a:r>
-              <a:t>Keep test results, deployed state and teardown proof separate; none implies the others.</a:t>
+              <a:t>Quota blocked the first NAT plan. Recovered apps ran, but apply was interrupted during old worker-group deletion.</a:t>
             </a:r>
           </a:p>
         </p:txBody>
@@ -3918,7 +3918,7 @@
               </a:defRPr>
             </a:pPr>
             <a:r>
-              <a:t>The demo has no authentication and uses a single PostgreSQL instance; production needs access control and a recovery plan.</a:t>
+              <a:t>Classroom demo: synthetic data, no authentication and one PostgreSQL instance. Production needs access control, backups and recovery testing.</a:t>
             </a:r>
           </a:p>
         </p:txBody>
@@ -6460,7 +6460,7 @@
               </a:defRPr>
             </a:pPr>
             <a:r>
-              <a:t>Capture successful plan, apply and console proof, then destroy temporary resources.</a:t>
+              <a:t>Recovered apps ran successfully. Apply was interrupted during old worker-group deletion; final destroy succeeded.</a:t>
             </a:r>
           </a:p>
         </p:txBody>
@@ -6990,7 +6990,7 @@
               </a:defRPr>
             </a:pPr>
             <a:r>
-              <a:t>Runtime evidence must show the actual pods, services, storage and health state.</a:t>
+              <a:t>Verified two frontend and two backend replicas, persistent gp3 storage and valid HPA CPU measurements.</a:t>
             </a:r>
           </a:p>
         </p:txBody>
@@ -7448,7 +7448,7 @@
               </a:defRPr>
             </a:pPr>
             <a:r>
-              <a:t>Show Synced and Healthy states, then demonstrate a controlled release update.</a:t>
+              <a:t>Recorded ArgoCD evidence shows the deployed application Synced and Healthy.</a:t>
             </a:r>
           </a:p>
         </p:txBody>
@@ -7520,7 +7520,7 @@
               </a:defRPr>
             </a:pPr>
             <a:r>
-              <a:t>A configured Application alone is not proof of a successful synchronization.</a:t>
+              <a:t>The backend replica field is ignored by ArgoCD so HPA can own scaling.</a:t>
             </a:r>
           </a:p>
         </p:txBody>

</xml_diff>